<commit_message>
docs(pptx): synchronize full-image presentation across all pptx files
</commit_message>
<xml_diff>
--- a/BaoCao_PhanMem_NB_Fashion.pptx
+++ b/BaoCao_PhanMem_NB_Fashion.pptx
@@ -11,6 +11,10 @@
     <p:sldId id="259" r:id="rId10"/>
     <p:sldId id="260" r:id="rId11"/>
     <p:sldId id="261" r:id="rId12"/>
+    <p:sldId id="262" r:id="rId13"/>
+    <p:sldId id="263" r:id="rId14"/>
+    <p:sldId id="264" r:id="rId15"/>
+    <p:sldId id="265" r:id="rId16"/>
   </p:sldIdLst>
   <p:sldSz cx="12188952" cy="6858000" type="screen4x3"/>
   <p:notesSz cx="6858000" cy="9144000"/>
@@ -3214,7 +3218,7 @@
               </a:defRPr>
             </a:pPr>
             <a:r>
-              <a:t>GIỚI THIỆU TỔNG QUAN PHẦN MỀM</a:t>
+              <a:t>ALBUM HÌNH ẢNH &amp; GIỚI THIỆU PHẦN MỀM</a:t>
             </a:r>
           </a:p>
           <a:p>
@@ -3226,7 +3230,7 @@
               </a:defRPr>
             </a:pPr>
             <a:r>
-              <a:t>NỀN TẢNG THỜI TRANG N&amp;B FASHION</a:t>
+              <a:t>HỆ THỐNG THỜI TRANG N&amp;B FASHION</a:t>
             </a:r>
           </a:p>
           <a:p>
@@ -3241,7 +3245,7 @@
               </a:defRPr>
             </a:pPr>
             <a:r>
-              <a:t>Tích Hợp Cửa Hàng TMĐT, Trợ Lý AI Stylist &amp; Thử Đồ 3D Web</a:t>
+              <a:t>Bộ Ảnh Chụp Thực Tế 8 Màn Hình Tính Năng Đã Vận Hành Hoàn Thiện</a:t>
             </a:r>
           </a:p>
           <a:p>
@@ -3256,7 +3260,7 @@
               </a:defRPr>
             </a:pPr>
             <a:r>
-              <a:t>Báo cáo trực quan các màn hình tính năng và quy trình luồng hoạt động thực tế của ứng dụng</a:t>
+              <a:t>Minh họa chi tiết: Cửa hàng TMĐT, Bộ lọc, Chi tiết sản phẩm, AI Stylist, Thử đồ 3D và Bưu cục GHN</a:t>
             </a:r>
           </a:p>
           <a:p>
@@ -3269,6 +3273,473 @@
             </a:pPr>
             <a:r>
               <a:t>Nhóm phát triển: Võ Minh Nhật  &amp;  Phạm Lê Gia Bảo</a:t>
+            </a:r>
+          </a:p>
+        </p:txBody>
+      </p:sp>
+    </p:spTree>
+  </p:cSld>
+  <p:clrMapOvr>
+    <a:masterClrMapping/>
+  </p:clrMapOvr>
+</p:sld>
+</file>
+
+<file path=ppt/slides/slide10.xml><?xml version="1.0" encoding="utf-8"?>
+<p:sld xmlns:a="http://schemas.openxmlformats.org/drawingml/2006/main" xmlns:p="http://schemas.openxmlformats.org/presentationml/2006/main" xmlns:r="http://schemas.openxmlformats.org/officeDocument/2006/relationships">
+  <p:cSld>
+    <p:spTree>
+      <p:nvGrpSpPr>
+        <p:cNvPr id="1" name=""/>
+        <p:cNvGrpSpPr/>
+        <p:nvPr/>
+      </p:nvGrpSpPr>
+      <p:grpSpPr/>
+      <p:sp>
+        <p:nvSpPr>
+          <p:cNvPr id="2" name="Rectangle 1"/>
+          <p:cNvSpPr/>
+          <p:nvPr/>
+        </p:nvSpPr>
+        <p:spPr>
+          <a:xfrm>
+            <a:off x="0" y="0"/>
+            <a:ext cx="12188952" cy="6858000"/>
+          </a:xfrm>
+          <a:prstGeom prst="rect">
+            <a:avLst/>
+          </a:prstGeom>
+          <a:solidFill>
+            <a:srgbClr val="F8FAFC"/>
+          </a:solidFill>
+          <a:ln>
+            <a:noFill/>
+          </a:ln>
+        </p:spPr>
+        <p:style>
+          <a:lnRef idx="1">
+            <a:schemeClr val="accent1"/>
+          </a:lnRef>
+          <a:fillRef idx="3">
+            <a:schemeClr val="accent1"/>
+          </a:fillRef>
+          <a:effectRef idx="2">
+            <a:schemeClr val="accent1"/>
+          </a:effectRef>
+          <a:fontRef idx="minor">
+            <a:schemeClr val="lt1"/>
+          </a:fontRef>
+        </p:style>
+        <p:txBody>
+          <a:bodyPr rtlCol="0" anchor="ctr"/>
+          <a:lstStyle/>
+          <a:p>
+            <a:pPr algn="ctr"/>
+          </a:p>
+        </p:txBody>
+      </p:sp>
+      <p:sp>
+        <p:nvSpPr>
+          <p:cNvPr id="3" name="TextBox 2"/>
+          <p:cNvSpPr txBox="1"/>
+          <p:nvPr/>
+        </p:nvSpPr>
+        <p:spPr>
+          <a:xfrm>
+            <a:off x="731520" y="320040"/>
+            <a:ext cx="7315200" cy="320040"/>
+          </a:xfrm>
+          <a:prstGeom prst="rect">
+            <a:avLst/>
+          </a:prstGeom>
+          <a:noFill/>
+        </p:spPr>
+        <p:txBody>
+          <a:bodyPr wrap="square">
+            <a:spAutoFit/>
+          </a:bodyPr>
+          <a:lstStyle/>
+          <a:p>
+            <a:pPr>
+              <a:defRPr sz="1100" b="1">
+                <a:solidFill>
+                  <a:srgbClr val="2563EB"/>
+                </a:solidFill>
+              </a:defRPr>
+            </a:pPr>
+            <a:r>
+              <a:t>TỔNG KẾT PHẦN MỀM</a:t>
+            </a:r>
+          </a:p>
+        </p:txBody>
+      </p:sp>
+      <p:sp>
+        <p:nvSpPr>
+          <p:cNvPr id="4" name="TextBox 3"/>
+          <p:cNvSpPr txBox="1"/>
+          <p:nvPr/>
+        </p:nvSpPr>
+        <p:spPr>
+          <a:xfrm>
+            <a:off x="731520" y="594360"/>
+            <a:ext cx="10515600" cy="502920"/>
+          </a:xfrm>
+          <a:prstGeom prst="rect">
+            <a:avLst/>
+          </a:prstGeom>
+          <a:noFill/>
+        </p:spPr>
+        <p:txBody>
+          <a:bodyPr wrap="square">
+            <a:spAutoFit/>
+          </a:bodyPr>
+          <a:lstStyle/>
+          <a:p>
+            <a:pPr>
+              <a:defRPr sz="2000" b="1">
+                <a:solidFill>
+                  <a:srgbClr val="0F172A"/>
+                </a:solidFill>
+              </a:defRPr>
+            </a:pPr>
+            <a:r>
+              <a:t>Tiến Độ Tính Năng: Đã Xong &amp; Đang Triển Khai</a:t>
+            </a:r>
+          </a:p>
+        </p:txBody>
+      </p:sp>
+      <p:sp>
+        <p:nvSpPr>
+          <p:cNvPr id="5" name="TextBox 4"/>
+          <p:cNvSpPr txBox="1"/>
+          <p:nvPr/>
+        </p:nvSpPr>
+        <p:spPr>
+          <a:xfrm>
+            <a:off x="731520" y="1097280"/>
+            <a:ext cx="10515600" cy="320040"/>
+          </a:xfrm>
+          <a:prstGeom prst="rect">
+            <a:avLst/>
+          </a:prstGeom>
+          <a:noFill/>
+        </p:spPr>
+        <p:txBody>
+          <a:bodyPr wrap="square">
+            <a:spAutoFit/>
+          </a:bodyPr>
+          <a:lstStyle/>
+          <a:p>
+            <a:pPr>
+              <a:defRPr sz="1150">
+                <a:solidFill>
+                  <a:srgbClr val="64748B"/>
+                </a:solidFill>
+              </a:defRPr>
+            </a:pPr>
+            <a:r>
+              <a:t>Báo cáo rõ ràng các phần đã vận hành tốt và các tính năng còn đang hoàn thiện</a:t>
+            </a:r>
+          </a:p>
+        </p:txBody>
+      </p:sp>
+      <p:sp>
+        <p:nvSpPr>
+          <p:cNvPr id="6" name="Rounded Rectangle 5"/>
+          <p:cNvSpPr/>
+          <p:nvPr/>
+        </p:nvSpPr>
+        <p:spPr>
+          <a:xfrm>
+            <a:off x="731520" y="1645920"/>
+            <a:ext cx="5120640" cy="4754880"/>
+          </a:xfrm>
+          <a:prstGeom prst="roundRect">
+            <a:avLst/>
+          </a:prstGeom>
+          <a:solidFill>
+            <a:srgbClr val="FFFFFF"/>
+          </a:solidFill>
+          <a:ln>
+            <a:solidFill>
+              <a:srgbClr val="E2E8F0"/>
+            </a:solidFill>
+          </a:ln>
+        </p:spPr>
+        <p:style>
+          <a:lnRef idx="1">
+            <a:schemeClr val="accent1"/>
+          </a:lnRef>
+          <a:fillRef idx="3">
+            <a:schemeClr val="accent1"/>
+          </a:fillRef>
+          <a:effectRef idx="2">
+            <a:schemeClr val="accent1"/>
+          </a:effectRef>
+          <a:fontRef idx="minor">
+            <a:schemeClr val="lt1"/>
+          </a:fontRef>
+        </p:style>
+        <p:txBody>
+          <a:bodyPr rtlCol="0" anchor="ctr"/>
+          <a:lstStyle/>
+          <a:p>
+            <a:pPr algn="ctr"/>
+          </a:p>
+        </p:txBody>
+      </p:sp>
+      <p:sp>
+        <p:nvSpPr>
+          <p:cNvPr id="7" name="TextBox 6"/>
+          <p:cNvSpPr txBox="1"/>
+          <p:nvPr/>
+        </p:nvSpPr>
+        <p:spPr>
+          <a:xfrm>
+            <a:off x="914400" y="1828800"/>
+            <a:ext cx="4754880" cy="4389120"/>
+          </a:xfrm>
+          <a:prstGeom prst="rect">
+            <a:avLst/>
+          </a:prstGeom>
+          <a:noFill/>
+        </p:spPr>
+        <p:txBody>
+          <a:bodyPr wrap="square">
+            <a:spAutoFit/>
+          </a:bodyPr>
+          <a:lstStyle/>
+          <a:p>
+            <a:pPr>
+              <a:spcAft>
+                <a:spcPts val="1200"/>
+              </a:spcAft>
+              <a:defRPr sz="1300" b="1">
+                <a:solidFill>
+                  <a:srgbClr val="16A34A"/>
+                </a:solidFill>
+              </a:defRPr>
+            </a:pPr>
+            <a:r>
+              <a:t>TÍNH NĂNG ĐÃ VẬN HÀNH TỐT (XONG)</a:t>
+            </a:r>
+          </a:p>
+          <a:p>
+            <a:pPr>
+              <a:spcAft>
+                <a:spcPts val="600"/>
+              </a:spcAft>
+              <a:defRPr sz="1050">
+                <a:solidFill>
+                  <a:srgbClr val="1E293B"/>
+                </a:solidFill>
+              </a:defRPr>
+            </a:pPr>
+            <a:r>
+              <a:t>✔ Cửa hàng TMĐT: Duyệt 55 sản phẩm, giỏ hàng, đặt hàng COD, khóa chống trùng đơn.</a:t>
+            </a:r>
+          </a:p>
+          <a:p>
+            <a:pPr>
+              <a:spcAft>
+                <a:spcPts val="600"/>
+              </a:spcAft>
+              <a:defRPr sz="1050">
+                <a:solidFill>
+                  <a:srgbClr val="1E293B"/>
+                </a:solidFill>
+              </a:defRPr>
+            </a:pPr>
+            <a:r>
+              <a:t>✔ Trợ lý AI Stylist: Tư vấn vóc dáng, cá nhân hóa theo tìm kiếm &amp; đơn cũ.</a:t>
+            </a:r>
+          </a:p>
+          <a:p>
+            <a:pPr>
+              <a:spcAft>
+                <a:spcPts val="600"/>
+              </a:spcAft>
+              <a:defRPr sz="1050">
+                <a:solidFill>
+                  <a:srgbClr val="1E293B"/>
+                </a:solidFill>
+              </a:defRPr>
+            </a:pPr>
+            <a:r>
+              <a:t>✔ Thẻ Combo Mua Sắm: Gợi ý 1 Áo + 1 Quần kèm nút Mua ngay 1-chạm.</a:t>
+            </a:r>
+          </a:p>
+          <a:p>
+            <a:pPr>
+              <a:spcAft>
+                <a:spcPts val="600"/>
+              </a:spcAft>
+              <a:defRPr sz="1050">
+                <a:solidFill>
+                  <a:srgbClr val="1E293B"/>
+                </a:solidFill>
+              </a:defRPr>
+            </a:pPr>
+            <a:r>
+              <a:t>✔ Phòng thử đồ 3D: Avatar co giãn theo số đo, xoay 360 độ, đổi màu sắc trang phục.</a:t>
+            </a:r>
+          </a:p>
+          <a:p>
+            <a:pPr>
+              <a:spcAft>
+                <a:spcPts val="600"/>
+              </a:spcAft>
+              <a:defRPr sz="1050">
+                <a:solidFill>
+                  <a:srgbClr val="1E293B"/>
+                </a:solidFill>
+              </a:defRPr>
+            </a:pPr>
+            <a:r>
+              <a:t>✔ Quản trị Admin &amp; GHN: Tạo mã vận đơn bưu điện thật, in phiếu giao hàng A4/A5.</a:t>
+            </a:r>
+          </a:p>
+          <a:p>
+            <a:pPr>
+              <a:spcAft>
+                <a:spcPts val="600"/>
+              </a:spcAft>
+              <a:defRPr sz="1050">
+                <a:solidFill>
+                  <a:srgbClr val="1E293B"/>
+                </a:solidFill>
+              </a:defRPr>
+            </a:pPr>
+            <a:r>
+              <a:t>✔ Bộ kiểm thử tự động: 78 pytest, 60 node test, 70 vitest pass 100%.</a:t>
+            </a:r>
+          </a:p>
+        </p:txBody>
+      </p:sp>
+      <p:sp>
+        <p:nvSpPr>
+          <p:cNvPr id="8" name="Rounded Rectangle 7"/>
+          <p:cNvSpPr/>
+          <p:nvPr/>
+        </p:nvSpPr>
+        <p:spPr>
+          <a:xfrm>
+            <a:off x="6126480" y="1645920"/>
+            <a:ext cx="5303520" cy="4754880"/>
+          </a:xfrm>
+          <a:prstGeom prst="roundRect">
+            <a:avLst/>
+          </a:prstGeom>
+          <a:solidFill>
+            <a:srgbClr val="FFFFFF"/>
+          </a:solidFill>
+          <a:ln>
+            <a:solidFill>
+              <a:srgbClr val="E2E8F0"/>
+            </a:solidFill>
+          </a:ln>
+        </p:spPr>
+        <p:style>
+          <a:lnRef idx="1">
+            <a:schemeClr val="accent1"/>
+          </a:lnRef>
+          <a:fillRef idx="3">
+            <a:schemeClr val="accent1"/>
+          </a:fillRef>
+          <a:effectRef idx="2">
+            <a:schemeClr val="accent1"/>
+          </a:effectRef>
+          <a:fontRef idx="minor">
+            <a:schemeClr val="lt1"/>
+          </a:fontRef>
+        </p:style>
+        <p:txBody>
+          <a:bodyPr rtlCol="0" anchor="ctr"/>
+          <a:lstStyle/>
+          <a:p>
+            <a:pPr algn="ctr"/>
+          </a:p>
+        </p:txBody>
+      </p:sp>
+      <p:sp>
+        <p:nvSpPr>
+          <p:cNvPr id="9" name="TextBox 8"/>
+          <p:cNvSpPr txBox="1"/>
+          <p:nvPr/>
+        </p:nvSpPr>
+        <p:spPr>
+          <a:xfrm>
+            <a:off x="6309360" y="1828800"/>
+            <a:ext cx="4937760" cy="4389120"/>
+          </a:xfrm>
+          <a:prstGeom prst="rect">
+            <a:avLst/>
+          </a:prstGeom>
+          <a:noFill/>
+        </p:spPr>
+        <p:txBody>
+          <a:bodyPr wrap="square">
+            <a:spAutoFit/>
+          </a:bodyPr>
+          <a:lstStyle/>
+          <a:p>
+            <a:pPr>
+              <a:spcAft>
+                <a:spcPts val="1200"/>
+              </a:spcAft>
+              <a:defRPr sz="1300" b="1">
+                <a:solidFill>
+                  <a:srgbClr val="D97706"/>
+                </a:solidFill>
+              </a:defRPr>
+            </a:pPr>
+            <a:r>
+              <a:t>TÍNH NĂNG CHƯA XONG / ĐANG LÀM</a:t>
+            </a:r>
+          </a:p>
+          <a:p>
+            <a:pPr>
+              <a:spcAft>
+                <a:spcPts val="1000"/>
+              </a:spcAft>
+              <a:defRPr sz="1100">
+                <a:solidFill>
+                  <a:srgbClr val="1E293B"/>
+                </a:solidFill>
+              </a:defRPr>
+            </a:pPr>
+            <a:r>
+              <a:t>⏳ Cổng thanh toán Chuyển khoản tự động: Hiện mới hỗ trợ thanh toán khi nhận hàng (COD), chưa tích hợp xong cổng đối soát tiền chuyển khoản qua ngân hàng.</a:t>
+            </a:r>
+          </a:p>
+          <a:p>
+            <a:pPr>
+              <a:spcAft>
+                <a:spcPts val="1000"/>
+              </a:spcAft>
+              <a:defRPr sz="1100">
+                <a:solidFill>
+                  <a:srgbClr val="1E293B"/>
+                </a:solidFill>
+              </a:defRPr>
+            </a:pPr>
+            <a:r>
+              <a:t>⏳ Thử đồ thời gian thực qua Webcam: Tính năng ướm thử trang phục trực tiếp qua camera máy tính/điện thoại người dùng đang trong giai đoạn nghiên cứu.</a:t>
+            </a:r>
+          </a:p>
+          <a:p>
+            <a:pPr>
+              <a:spcAft>
+                <a:spcPts val="1000"/>
+              </a:spcAft>
+              <a:defRPr sz="1100">
+                <a:solidFill>
+                  <a:srgbClr val="1E293B"/>
+                </a:solidFill>
+              </a:defRPr>
+            </a:pPr>
+            <a:r>
+              <a:t>⏳ Tinh chỉnh hiển thị phòng 3D: Cần hoàn thiện thêm độ khớp của phom đồ 3D và tối ưu hiệu năng hiển thị trên thiết bị di động (Mobile WebGL).</a:t>
             </a:r>
           </a:p>
         </p:txBody>
@@ -3342,7 +3813,7 @@
         </p:nvSpPr>
         <p:spPr>
           <a:xfrm>
-            <a:off x="731520" y="365760"/>
+            <a:off x="731520" y="320040"/>
             <a:ext cx="7315200" cy="320040"/>
           </a:xfrm>
           <a:prstGeom prst="rect">
@@ -3364,7 +3835,7 @@
               </a:defRPr>
             </a:pPr>
             <a:r>
-              <a:t>CHỨC NĂNG 01</a:t>
+              <a:t>MÀN HÌNH 01</a:t>
             </a:r>
           </a:p>
         </p:txBody>
@@ -3377,7 +3848,7 @@
         </p:nvSpPr>
         <p:spPr>
           <a:xfrm>
-            <a:off x="731520" y="640080"/>
+            <a:off x="731520" y="594360"/>
             <a:ext cx="10515600" cy="502920"/>
           </a:xfrm>
           <a:prstGeom prst="rect">
@@ -3399,7 +3870,7 @@
               </a:defRPr>
             </a:pPr>
             <a:r>
-              <a:t>Cửa Hàng TMĐT: Xem Sản Phẩm &amp; Đặt Hàng</a:t>
+              <a:t>Trang Chủ &amp; Banner Thương Hiệu N&amp;B</a:t>
             </a:r>
           </a:p>
         </p:txBody>
@@ -3412,7 +3883,7 @@
         </p:nvSpPr>
         <p:spPr>
           <a:xfrm>
-            <a:off x="731520" y="1143000"/>
+            <a:off x="731520" y="1097280"/>
             <a:ext cx="10515600" cy="320040"/>
           </a:xfrm>
           <a:prstGeom prst="rect">
@@ -3434,7 +3905,7 @@
               </a:defRPr>
             </a:pPr>
             <a:r>
-              <a:t>Giao diện mua sắm hiện đại, phân loại thời trang và đặt hàng an toàn</a:t>
+              <a:t>Giao diện hiện đại, sang trọng, định hình phong cách thời trang cao cấp</a:t>
             </a:r>
           </a:p>
         </p:txBody>
@@ -3447,8 +3918,8 @@
         </p:nvSpPr>
         <p:spPr>
           <a:xfrm>
-            <a:off x="731520" y="1645920"/>
-            <a:ext cx="4389120" cy="4754880"/>
+            <a:off x="731520" y="1554480"/>
+            <a:ext cx="4114800" cy="4846320"/>
           </a:xfrm>
           <a:prstGeom prst="roundRect">
             <a:avLst/>
@@ -3492,8 +3963,8 @@
         </p:nvSpPr>
         <p:spPr>
           <a:xfrm>
-            <a:off x="914400" y="1828800"/>
-            <a:ext cx="4023360" cy="4389120"/>
+            <a:off x="914400" y="1737360"/>
+            <a:ext cx="3749039" cy="4480560"/>
           </a:xfrm>
           <a:prstGeom prst="rect">
             <a:avLst/>
@@ -3517,13 +3988,13 @@
               </a:defRPr>
             </a:pPr>
             <a:r>
-              <a:t>CÁC ĐIỂM NỔI BẬT ĐÃ HOÀN THÀNH</a:t>
+              <a:t>CÁC ĐIỂM NỔI BẬT</a:t>
             </a:r>
           </a:p>
           <a:p>
             <a:pPr>
               <a:spcAft>
-                <a:spcPts val="600"/>
+                <a:spcPts val="800"/>
               </a:spcAft>
               <a:defRPr sz="1050">
                 <a:solidFill>
@@ -3532,13 +4003,13 @@
               </a:defRPr>
             </a:pPr>
             <a:r>
-              <a:t>✔ 55 dòng sản phẩm cao cấp: Sơ mi Oxford, Áo thun Graphic, Quần tây, Chân váy.</a:t>
+              <a:t>✔ Banner thương hiệu N&amp;B Atelier chuyên nghiệp, phong cách tối giản.</a:t>
             </a:r>
           </a:p>
           <a:p>
             <a:pPr>
               <a:spcAft>
-                <a:spcPts val="600"/>
+                <a:spcPts val="800"/>
               </a:spcAft>
               <a:defRPr sz="1050">
                 <a:solidFill>
@@ -3547,13 +4018,13 @@
               </a:defRPr>
             </a:pPr>
             <a:r>
-              <a:t>✔ 118 biến thể màu sắc có ảnh chụp studio góc trước và góc sau.</a:t>
+              <a:t>✔ Hiển thị bộ sưu tập nổi bật mùa mới (Áo thun, Sơ mi, Quần dài, Váy).</a:t>
             </a:r>
           </a:p>
           <a:p>
             <a:pPr>
               <a:spcAft>
-                <a:spcPts val="600"/>
+                <a:spcPts val="800"/>
               </a:spcAft>
               <a:defRPr sz="1050">
                 <a:solidFill>
@@ -3562,13 +4033,13 @@
               </a:defRPr>
             </a:pPr>
             <a:r>
-              <a:t>✔ Bộ lọc đa chiều: Lọc theo kích thước (S/M/L/XL), phân loại, khoảng giá.</a:t>
+              <a:t>✔ Thanh điều hướng thông minh: Phân loại đồ Nam, đồ Nữ, Giỏ hàng.</a:t>
             </a:r>
           </a:p>
           <a:p>
             <a:pPr>
               <a:spcAft>
-                <a:spcPts val="600"/>
+                <a:spcPts val="800"/>
               </a:spcAft>
               <a:defRPr sz="1050">
                 <a:solidFill>
@@ -3577,44 +4048,14 @@
               </a:defRPr>
             </a:pPr>
             <a:r>
-              <a:t>✔ Tự động lưu lịch sử tìm kiếm người dùng (để gợi ý đúng gu).</a:t>
-            </a:r>
-          </a:p>
-          <a:p>
-            <a:pPr>
-              <a:spcAft>
-                <a:spcPts val="600"/>
-              </a:spcAft>
-              <a:defRPr sz="1050">
-                <a:solidFill>
-                  <a:srgbClr val="1E293B"/>
-                </a:solidFill>
-              </a:defRPr>
-            </a:pPr>
-            <a:r>
-              <a:t>✔ Giỏ hàng thời gian thực, cơ chế khóa Checkout chống trùng đơn.</a:t>
-            </a:r>
-          </a:p>
-          <a:p>
-            <a:pPr>
-              <a:spcAft>
-                <a:spcPts val="600"/>
-              </a:spcAft>
-              <a:defRPr sz="1050">
-                <a:solidFill>
-                  <a:srgbClr val="1E293B"/>
-                </a:solidFill>
-              </a:defRPr>
-            </a:pPr>
-            <a:r>
-              <a:t>✔ Thanh toán nhận hàng COD an toàn, lưu sổ địa chỉ đa điểm.</a:t>
+              <a:t>✔ Tích hợp nút kích hoạt nhanh Trợ lý AI Stylist ở góc phải màn hình.</a:t>
             </a:r>
           </a:p>
         </p:txBody>
       </p:sp>
       <p:pic>
         <p:nvPicPr>
-          <p:cNvPr id="8" name="Picture 7" descr="screenshot_shop.png"/>
+          <p:cNvPr id="8" name="Picture 7" descr="shot_01_home.png"/>
           <p:cNvPicPr>
             <a:picLocks noChangeAspect="1"/>
           </p:cNvPicPr>
@@ -3628,8 +4069,8 @@
         </p:blipFill>
         <p:spPr>
           <a:xfrm>
-            <a:off x="5303520" y="1645920"/>
-            <a:ext cx="6126480" cy="4754880"/>
+            <a:off x="5029200" y="1554480"/>
+            <a:ext cx="6400800" cy="4846320"/>
           </a:xfrm>
           <a:prstGeom prst="rect">
             <a:avLst/>
@@ -3705,7 +4146,7 @@
         </p:nvSpPr>
         <p:spPr>
           <a:xfrm>
-            <a:off x="731520" y="365760"/>
+            <a:off x="731520" y="320040"/>
             <a:ext cx="7315200" cy="320040"/>
           </a:xfrm>
           <a:prstGeom prst="rect">
@@ -3727,7 +4168,7 @@
               </a:defRPr>
             </a:pPr>
             <a:r>
-              <a:t>CHỨC NĂNG 02</a:t>
+              <a:t>MÀN HÌNH 02</a:t>
             </a:r>
           </a:p>
         </p:txBody>
@@ -3740,7 +4181,7 @@
         </p:nvSpPr>
         <p:spPr>
           <a:xfrm>
-            <a:off x="731520" y="640080"/>
+            <a:off x="731520" y="594360"/>
             <a:ext cx="10515600" cy="502920"/>
           </a:xfrm>
           <a:prstGeom prst="rect">
@@ -3762,7 +4203,7 @@
               </a:defRPr>
             </a:pPr>
             <a:r>
-              <a:t>Trợ Lý AI Stylist &amp; Thẻ Combo Mua Sắm</a:t>
+              <a:t>Danh Mục Sản Phẩm &amp; Bộ Lọc Đa Chiều</a:t>
             </a:r>
           </a:p>
         </p:txBody>
@@ -3775,7 +4216,7 @@
         </p:nvSpPr>
         <p:spPr>
           <a:xfrm>
-            <a:off x="731520" y="1143000"/>
+            <a:off x="731520" y="1097280"/>
             <a:ext cx="10515600" cy="320040"/>
           </a:xfrm>
           <a:prstGeom prst="rect">
@@ -3797,7 +4238,7 @@
               </a:defRPr>
             </a:pPr>
             <a:r>
-              <a:t>Tư vấn phối đồ thông minh theo số đo và lịch sử người dùng kèm nút mua ngay 1-chạm</a:t>
+              <a:t>55 dòng sản phẩm cao cấp, 118 màu có hình studio và lọc thông minh</a:t>
             </a:r>
           </a:p>
         </p:txBody>
@@ -3810,8 +4251,8 @@
         </p:nvSpPr>
         <p:spPr>
           <a:xfrm>
-            <a:off x="731520" y="1645920"/>
-            <a:ext cx="4389120" cy="4754880"/>
+            <a:off x="731520" y="1554480"/>
+            <a:ext cx="4114800" cy="4846320"/>
           </a:xfrm>
           <a:prstGeom prst="roundRect">
             <a:avLst/>
@@ -3855,8 +4296,8 @@
         </p:nvSpPr>
         <p:spPr>
           <a:xfrm>
-            <a:off x="914400" y="1828800"/>
-            <a:ext cx="4023360" cy="4389120"/>
+            <a:off x="914400" y="1737360"/>
+            <a:ext cx="3749039" cy="4480560"/>
           </a:xfrm>
           <a:prstGeom prst="rect">
             <a:avLst/>
@@ -3880,13 +4321,13 @@
               </a:defRPr>
             </a:pPr>
             <a:r>
-              <a:t>CÁC ĐIỂM NỔI BẬT ĐÃ HOÀN THÀNH</a:t>
+              <a:t>CÁC ĐIỂM NỔI BẬT</a:t>
             </a:r>
           </a:p>
           <a:p>
             <a:pPr>
               <a:spcAft>
-                <a:spcPts val="600"/>
+                <a:spcPts val="800"/>
               </a:spcAft>
               <a:defRPr sz="1050">
                 <a:solidFill>
@@ -3895,13 +4336,13 @@
               </a:defRPr>
             </a:pPr>
             <a:r>
-              <a:t>✔ Chatbox AI Stylist: Tích hợp Google Gemini LLM phản hồi nhanh.</a:t>
+              <a:t>✔ Kho sản phẩm lớn: 55 dòng thời trang cao cấp với 118 biến thể màu.</a:t>
             </a:r>
           </a:p>
           <a:p>
             <a:pPr>
               <a:spcAft>
-                <a:spcPts val="600"/>
+                <a:spcPts val="800"/>
               </a:spcAft>
               <a:defRPr sz="1050">
                 <a:solidFill>
@@ -3910,13 +4351,13 @@
               </a:defRPr>
             </a:pPr>
             <a:r>
-              <a:t>✔ Đoán size thông minh: Nhận diện chiều cao/cân nặng để khuyên size chuẩn.</a:t>
+              <a:t>✔ Bộ lọc kích thước: Lọc nhanh theo size S, M, L, XL.</a:t>
             </a:r>
           </a:p>
           <a:p>
             <a:pPr>
               <a:spcAft>
-                <a:spcPts val="600"/>
+                <a:spcPts val="800"/>
               </a:spcAft>
               <a:defRPr sz="1050">
                 <a:solidFill>
@@ -3925,13 +4366,13 @@
               </a:defRPr>
             </a:pPr>
             <a:r>
-              <a:t>✔ Cá nhân hóa theo lịch sử tìm kiếm: Bắt đúng phong cách khách đang tìm.</a:t>
+              <a:t>✔ Bộ lọc mức giá: Kéo thanh trượt chọn khoảng giá mong muốn.</a:t>
             </a:r>
           </a:p>
           <a:p>
             <a:pPr>
               <a:spcAft>
-                <a:spcPts val="600"/>
+                <a:spcPts val="800"/>
               </a:spcAft>
               <a:defRPr sz="1050">
                 <a:solidFill>
@@ -3940,44 +4381,14 @@
               </a:defRPr>
             </a:pPr>
             <a:r>
-              <a:t>✔ Cá nhân hóa theo đơn hàng cũ: Gợi ý đồ mới phối chéo với đồ cũ trong tủ.</a:t>
-            </a:r>
-          </a:p>
-          <a:p>
-            <a:pPr>
-              <a:spcAft>
-                <a:spcPts val="600"/>
-              </a:spcAft>
-              <a:defRPr sz="1050">
-                <a:solidFill>
-                  <a:srgbClr val="1E293B"/>
-                </a:solidFill>
-              </a:defRPr>
-            </a:pPr>
-            <a:r>
-              <a:t>✔ Thẻ Combo Mua Sắm: Tự động ghép 1 Áo + 1 Quần có ảnh thật và giá tiền.</a:t>
-            </a:r>
-          </a:p>
-          <a:p>
-            <a:pPr>
-              <a:spcAft>
-                <a:spcPts val="600"/>
-              </a:spcAft>
-              <a:defRPr sz="1050">
-                <a:solidFill>
-                  <a:srgbClr val="1E293B"/>
-                </a:solidFill>
-              </a:defRPr>
-            </a:pPr>
-            <a:r>
-              <a:t>✔ Nút 'Thêm vào giỏ' &amp; 'Mua ngay': Mua nguyên set chỉ trong 1 lần click.</a:t>
+              <a:t>✔ Lưới hiển thị sản phẩm trực quan, hiển thị tag giá và màu sắc sắc nét.</a:t>
             </a:r>
           </a:p>
         </p:txBody>
       </p:sp>
       <p:pic>
         <p:nvPicPr>
-          <p:cNvPr id="8" name="Picture 7" descr="screenshot_stylist.png"/>
+          <p:cNvPr id="8" name="Picture 7" descr="shot_02_catalog.png"/>
           <p:cNvPicPr>
             <a:picLocks noChangeAspect="1"/>
           </p:cNvPicPr>
@@ -3991,8 +4402,8 @@
         </p:blipFill>
         <p:spPr>
           <a:xfrm>
-            <a:off x="5303520" y="1645920"/>
-            <a:ext cx="6126480" cy="4754880"/>
+            <a:off x="5029200" y="1554480"/>
+            <a:ext cx="6400800" cy="4846320"/>
           </a:xfrm>
           <a:prstGeom prst="rect">
             <a:avLst/>
@@ -4068,7 +4479,7 @@
         </p:nvSpPr>
         <p:spPr>
           <a:xfrm>
-            <a:off x="731520" y="365760"/>
+            <a:off x="731520" y="320040"/>
             <a:ext cx="7315200" cy="320040"/>
           </a:xfrm>
           <a:prstGeom prst="rect">
@@ -4090,7 +4501,7 @@
               </a:defRPr>
             </a:pPr>
             <a:r>
-              <a:t>CHỨC NĂNG 03</a:t>
+              <a:t>MÀN HÌNH 03</a:t>
             </a:r>
           </a:p>
         </p:txBody>
@@ -4103,7 +4514,7 @@
         </p:nvSpPr>
         <p:spPr>
           <a:xfrm>
-            <a:off x="731520" y="640080"/>
+            <a:off x="731520" y="594360"/>
             <a:ext cx="10515600" cy="502920"/>
           </a:xfrm>
           <a:prstGeom prst="rect">
@@ -4125,7 +4536,7 @@
               </a:defRPr>
             </a:pPr>
             <a:r>
-              <a:t>Phòng Thử Đồ 3D (Virtual Try-On WebGL)</a:t>
+              <a:t>Trang Chi Tiết Sản Phẩm &amp; Nút Thử Đồ 3D</a:t>
             </a:r>
           </a:p>
         </p:txBody>
@@ -4138,7 +4549,7 @@
         </p:nvSpPr>
         <p:spPr>
           <a:xfrm>
-            <a:off x="731520" y="1143000"/>
+            <a:off x="731520" y="1097280"/>
             <a:ext cx="10515600" cy="320040"/>
           </a:xfrm>
           <a:prstGeom prst="rect">
@@ -4160,7 +4571,7 @@
               </a:defRPr>
             </a:pPr>
             <a:r>
-              <a:t>Mô phỏng trang phục 3D trực tiếp trên trình duyệt Web không cần cài cắm app</a:t>
+              <a:t>Thông tin chất liệu, chọn màu sắc thời gian thực và liên kết phòng thử 3D</a:t>
             </a:r>
           </a:p>
         </p:txBody>
@@ -4173,8 +4584,8 @@
         </p:nvSpPr>
         <p:spPr>
           <a:xfrm>
-            <a:off x="731520" y="1645920"/>
-            <a:ext cx="4389120" cy="4754880"/>
+            <a:off x="731520" y="1554480"/>
+            <a:ext cx="4114800" cy="4846320"/>
           </a:xfrm>
           <a:prstGeom prst="roundRect">
             <a:avLst/>
@@ -4218,8 +4629,8 @@
         </p:nvSpPr>
         <p:spPr>
           <a:xfrm>
-            <a:off x="914400" y="1828800"/>
-            <a:ext cx="4023360" cy="4389120"/>
+            <a:off x="914400" y="1737360"/>
+            <a:ext cx="3749039" cy="4480560"/>
           </a:xfrm>
           <a:prstGeom prst="rect">
             <a:avLst/>
@@ -4243,13 +4654,13 @@
               </a:defRPr>
             </a:pPr>
             <a:r>
-              <a:t>CÁC ĐIỂM NỔI BẬT ĐÃ HOÀN THÀNH</a:t>
+              <a:t>CÁC ĐIỂM NỔI BẬT</a:t>
             </a:r>
           </a:p>
           <a:p>
             <a:pPr>
               <a:spcAft>
-                <a:spcPts val="600"/>
+                <a:spcPts val="800"/>
               </a:spcAft>
               <a:defRPr sz="1050">
                 <a:solidFill>
@@ -4258,13 +4669,13 @@
               </a:defRPr>
             </a:pPr>
             <a:r>
-              <a:t>✔ Avatar 3D tự động co giãn theo Chiều cao &amp; Cân nặng của khách.</a:t>
+              <a:t>✔ Ảnh chụp studio phóng to chi tiết góc trước và góc sau sản phẩm.</a:t>
             </a:r>
           </a:p>
           <a:p>
             <a:pPr>
               <a:spcAft>
-                <a:spcPts val="600"/>
+                <a:spcPts val="800"/>
               </a:spcAft>
               <a:defRPr sz="1050">
                 <a:solidFill>
@@ -4273,13 +4684,13 @@
               </a:defRPr>
             </a:pPr>
             <a:r>
-              <a:t>✔ Hỗ trợ cả người mẫu Nam (chuẩn M1) và Nữ (chuẩn F2).</a:t>
+              <a:t>✔ Bảng chọn biến thể màu sắc (Color Swatches) trực quan.</a:t>
             </a:r>
           </a:p>
           <a:p>
             <a:pPr>
               <a:spcAft>
-                <a:spcPts val="600"/>
+                <a:spcPts val="800"/>
               </a:spcAft>
               <a:defRPr sz="1050">
                 <a:solidFill>
@@ -4288,13 +4699,13 @@
               </a:defRPr>
             </a:pPr>
             <a:r>
-              <a:t>✔ Chạy mượt mà trên nền tảng Three.js / WebGL, xoay 360 độ linh hoạt.</a:t>
+              <a:t>✔ Nút chọn size S / M / L / XL kèm hướng dẫn kích cỡ.</a:t>
             </a:r>
           </a:p>
           <a:p>
             <a:pPr>
               <a:spcAft>
-                <a:spcPts val="600"/>
+                <a:spcPts val="800"/>
               </a:spcAft>
               <a:defRPr sz="1050">
                 <a:solidFill>
@@ -4303,44 +4714,14 @@
               </a:defRPr>
             </a:pPr>
             <a:r>
-              <a:t>✔ Thử các sản phẩm: Áo sơ mi Oxford, Áo thun Graphic, Quần tây đen, Váy.</a:t>
-            </a:r>
-          </a:p>
-          <a:p>
-            <a:pPr>
-              <a:spcAft>
-                <a:spcPts val="600"/>
-              </a:spcAft>
-              <a:defRPr sz="1050">
-                <a:solidFill>
-                  <a:srgbClr val="1E293B"/>
-                </a:solidFill>
-              </a:defRPr>
-            </a:pPr>
-            <a:r>
-              <a:t>✔ Đổi màu sắc áo quần linh hoạt theo kho hàng.</a:t>
-            </a:r>
-          </a:p>
-          <a:p>
-            <a:pPr>
-              <a:spcAft>
-                <a:spcPts val="600"/>
-              </a:spcAft>
-              <a:defRPr sz="1050">
-                <a:solidFill>
-                  <a:srgbClr val="1E293B"/>
-                </a:solidFill>
-              </a:defRPr>
-            </a:pPr>
-            <a:r>
-              <a:t>✔ Thẻ Fit Card đo độ dư cử động (+11.8cm) và đánh giá độ vừa vặn thực tế.</a:t>
+              <a:t>✔ Nút 'Thử đồ 3D': Chuyển ngay sản phẩm sang phòng thử đồ 3D để ướm thử.</a:t>
             </a:r>
           </a:p>
         </p:txBody>
       </p:sp>
       <p:pic>
         <p:nvPicPr>
-          <p:cNvPr id="8" name="Picture 7" descr="screenshot_tryon.png"/>
+          <p:cNvPr id="8" name="Picture 7" descr="shot_03_detail.png"/>
           <p:cNvPicPr>
             <a:picLocks noChangeAspect="1"/>
           </p:cNvPicPr>
@@ -4354,8 +4735,8 @@
         </p:blipFill>
         <p:spPr>
           <a:xfrm>
-            <a:off x="5303520" y="1645920"/>
-            <a:ext cx="6126480" cy="4754880"/>
+            <a:off x="5029200" y="1554480"/>
+            <a:ext cx="6400800" cy="4846320"/>
           </a:xfrm>
           <a:prstGeom prst="rect">
             <a:avLst/>
@@ -4431,7 +4812,7 @@
         </p:nvSpPr>
         <p:spPr>
           <a:xfrm>
-            <a:off x="731520" y="365760"/>
+            <a:off x="731520" y="320040"/>
             <a:ext cx="7315200" cy="320040"/>
           </a:xfrm>
           <a:prstGeom prst="rect">
@@ -4453,7 +4834,7 @@
               </a:defRPr>
             </a:pPr>
             <a:r>
-              <a:t>CHỨC NĂNG 04</a:t>
+              <a:t>MÀN HÌNH 04</a:t>
             </a:r>
           </a:p>
         </p:txBody>
@@ -4466,7 +4847,7 @@
         </p:nvSpPr>
         <p:spPr>
           <a:xfrm>
-            <a:off x="731520" y="640080"/>
+            <a:off x="731520" y="594360"/>
             <a:ext cx="10515600" cy="502920"/>
           </a:xfrm>
           <a:prstGeom prst="rect">
@@ -4488,7 +4869,7 @@
               </a:defRPr>
             </a:pPr>
             <a:r>
-              <a:t>Quản Trị Admin &amp; Giao Vận Bưu Cục GHN</a:t>
+              <a:t>Trợ Lý AI Stylist &amp; Thẻ Combo Mua Sắm 1-Chạm</a:t>
             </a:r>
           </a:p>
         </p:txBody>
@@ -4501,7 +4882,7 @@
         </p:nvSpPr>
         <p:spPr>
           <a:xfrm>
-            <a:off x="731520" y="1143000"/>
+            <a:off x="731520" y="1097280"/>
             <a:ext cx="10515600" cy="320040"/>
           </a:xfrm>
           <a:prstGeom prst="rect">
@@ -4523,7 +4904,7 @@
               </a:defRPr>
             </a:pPr>
             <a:r>
-              <a:t>Tự động hóa hoàn toàn quy trình duyệt đơn, tạo vận đơn bưu cục và in phiếu giao hàng</a:t>
+              <a:t>Phối đồ cá nhân hóa dựa trên số đo, lịch sử tìm kiếm và đơn hàng cũ</a:t>
             </a:r>
           </a:p>
         </p:txBody>
@@ -4536,8 +4917,8 @@
         </p:nvSpPr>
         <p:spPr>
           <a:xfrm>
-            <a:off x="731520" y="1645920"/>
-            <a:ext cx="4389120" cy="4754880"/>
+            <a:off x="731520" y="1554480"/>
+            <a:ext cx="4114800" cy="4846320"/>
           </a:xfrm>
           <a:prstGeom prst="roundRect">
             <a:avLst/>
@@ -4581,8 +4962,8 @@
         </p:nvSpPr>
         <p:spPr>
           <a:xfrm>
-            <a:off x="914400" y="1828800"/>
-            <a:ext cx="4023360" cy="4389120"/>
+            <a:off x="914400" y="1737360"/>
+            <a:ext cx="3749039" cy="4480560"/>
           </a:xfrm>
           <a:prstGeom prst="rect">
             <a:avLst/>
@@ -4606,13 +4987,13 @@
               </a:defRPr>
             </a:pPr>
             <a:r>
-              <a:t>CÁC ĐIỂM NỔI BẬT ĐÃ HOÀN THÀNH</a:t>
+              <a:t>CÁC ĐIỂM NỔI BẬT</a:t>
             </a:r>
           </a:p>
           <a:p>
             <a:pPr>
               <a:spcAft>
-                <a:spcPts val="600"/>
+                <a:spcPts val="800"/>
               </a:spcAft>
               <a:defRPr sz="1050">
                 <a:solidFill>
@@ -4621,13 +5002,13 @@
               </a:defRPr>
             </a:pPr>
             <a:r>
-              <a:t>✔ Dashboard Admin: Theo dõi danh sách đơn hàng và thông tin khách hàng.</a:t>
+              <a:t>✔ Chatbox AI Stylist kết nối mô hình Google Gemini LLM phản hồi nhanh.</a:t>
             </a:r>
           </a:p>
           <a:p>
             <a:pPr>
               <a:spcAft>
-                <a:spcPts val="600"/>
+                <a:spcPts val="800"/>
               </a:spcAft>
               <a:defRPr sz="1050">
                 <a:solidFill>
@@ -4636,13 +5017,13 @@
               </a:defRPr>
             </a:pPr>
             <a:r>
-              <a:t>✔ 1-Click tạo vận đơn GHN: Gọi trực tiếp API Giao Hàng Nhanh sinh mã bưu điện thật.</a:t>
+              <a:t>✔ Cá nhân hóa theo số đo Chiều cao/Cân nặng để tư vấn size chuẩn xác.</a:t>
             </a:r>
           </a:p>
           <a:p>
             <a:pPr>
               <a:spcAft>
-                <a:spcPts val="600"/>
+                <a:spcPts val="800"/>
               </a:spcAft>
               <a:defRPr sz="1050">
                 <a:solidFill>
@@ -4651,13 +5032,13 @@
               </a:defRPr>
             </a:pPr>
             <a:r>
-              <a:t>✔ Mã vận đơn xuất hiện tức thì trên hệ thống bưu tá 5sao.ghn.dev.</a:t>
+              <a:t>✔ Đọc lịch sử tìm kiếm &amp; đơn cũ để gợi ý phối chéo với tủ đồ có sẵn.</a:t>
             </a:r>
           </a:p>
           <a:p>
             <a:pPr>
               <a:spcAft>
-                <a:spcPts val="600"/>
+                <a:spcPts val="800"/>
               </a:spcAft>
               <a:defRPr sz="1050">
                 <a:solidFill>
@@ -4666,29 +5047,14 @@
               </a:defRPr>
             </a:pPr>
             <a:r>
-              <a:t>✔ In phiếu đóng hàng A4/A5 chuẩn bưu điện có sẵn mã vạch Barcode SVG.</a:t>
-            </a:r>
-          </a:p>
-          <a:p>
-            <a:pPr>
-              <a:spcAft>
-                <a:spcPts val="600"/>
-              </a:spcAft>
-              <a:defRPr sz="1050">
-                <a:solidFill>
-                  <a:srgbClr val="1E293B"/>
-                </a:solidFill>
-              </a:defRPr>
-            </a:pPr>
-            <a:r>
-              <a:t>✔ Khách hàng bấm vào mã vận đơn để tra cứu lộ trình bưu phẩm trực tiếp.</a:t>
+              <a:t>✔ Thẻ Combo Mua Sắm: Tự động ghép 1 Áo + 1 Quần có ảnh thật, giá tiền, nút 'Thêm giỏ' và 'Mua ngay' 1-chạm.</a:t>
             </a:r>
           </a:p>
         </p:txBody>
       </p:sp>
       <p:pic>
         <p:nvPicPr>
-          <p:cNvPr id="8" name="Picture 7" descr="screenshot_admin.png"/>
+          <p:cNvPr id="8" name="Picture 7" descr="shot_05_stylist.png"/>
           <p:cNvPicPr>
             <a:picLocks noChangeAspect="1"/>
           </p:cNvPicPr>
@@ -4702,8 +5068,8 @@
         </p:blipFill>
         <p:spPr>
           <a:xfrm>
-            <a:off x="5303520" y="1645920"/>
-            <a:ext cx="6126480" cy="4754880"/>
+            <a:off x="5029200" y="1554480"/>
+            <a:ext cx="6400800" cy="4846320"/>
           </a:xfrm>
           <a:prstGeom prst="rect">
             <a:avLst/>
@@ -4779,7 +5145,7 @@
         </p:nvSpPr>
         <p:spPr>
           <a:xfrm>
-            <a:off x="731520" y="365760"/>
+            <a:off x="731520" y="320040"/>
             <a:ext cx="7315200" cy="320040"/>
           </a:xfrm>
           <a:prstGeom prst="rect">
@@ -4801,7 +5167,7 @@
               </a:defRPr>
             </a:pPr>
             <a:r>
-              <a:t>TỔNG KẾT PHẦN MỀM</a:t>
+              <a:t>MÀN HÌNH 05</a:t>
             </a:r>
           </a:p>
         </p:txBody>
@@ -4814,7 +5180,7 @@
         </p:nvSpPr>
         <p:spPr>
           <a:xfrm>
-            <a:off x="731520" y="640080"/>
+            <a:off x="731520" y="594360"/>
             <a:ext cx="10515600" cy="502920"/>
           </a:xfrm>
           <a:prstGeom prst="rect">
@@ -4836,7 +5202,7 @@
               </a:defRPr>
             </a:pPr>
             <a:r>
-              <a:t>Tiến Độ Tính Năng: Đã Xong &amp; Đang Triển Khai</a:t>
+              <a:t>Phòng Thử Đồ 3D (Virtual Try-On WebGL)</a:t>
             </a:r>
           </a:p>
         </p:txBody>
@@ -4849,7 +5215,7 @@
         </p:nvSpPr>
         <p:spPr>
           <a:xfrm>
-            <a:off x="731520" y="1143000"/>
+            <a:off x="731520" y="1097280"/>
             <a:ext cx="10515600" cy="320040"/>
           </a:xfrm>
           <a:prstGeom prst="rect">
@@ -4871,7 +5237,7 @@
               </a:defRPr>
             </a:pPr>
             <a:r>
-              <a:t>Báo cáo rõ ràng các phần đã vận hành tốt và các tính năng còn đang hoàn thiện</a:t>
+              <a:t>Ướm trang phục trực quan trên trình duyệt Web không cần cài cắm app</a:t>
             </a:r>
           </a:p>
         </p:txBody>
@@ -4884,8 +5250,8 @@
         </p:nvSpPr>
         <p:spPr>
           <a:xfrm>
-            <a:off x="731520" y="1645920"/>
-            <a:ext cx="5120640" cy="4754880"/>
+            <a:off x="731520" y="1554480"/>
+            <a:ext cx="4114800" cy="4846320"/>
           </a:xfrm>
           <a:prstGeom prst="roundRect">
             <a:avLst/>
@@ -4929,8 +5295,8 @@
         </p:nvSpPr>
         <p:spPr>
           <a:xfrm>
-            <a:off x="914400" y="1828800"/>
-            <a:ext cx="4754880" cy="4389120"/>
+            <a:off x="914400" y="1737360"/>
+            <a:ext cx="3749039" cy="4480560"/>
           </a:xfrm>
           <a:prstGeom prst="rect">
             <a:avLst/>
@@ -4947,20 +5313,20 @@
               <a:spcAft>
                 <a:spcPts val="1200"/>
               </a:spcAft>
-              <a:defRPr sz="1300" b="1">
-                <a:solidFill>
-                  <a:srgbClr val="16A34A"/>
-                </a:solidFill>
-              </a:defRPr>
-            </a:pPr>
-            <a:r>
-              <a:t>TÍNH NĂNG ĐÃ VẬN HÀNH TỐT (XONG)</a:t>
+              <a:defRPr sz="1200" b="1">
+                <a:solidFill>
+                  <a:srgbClr val="2563EB"/>
+                </a:solidFill>
+              </a:defRPr>
+            </a:pPr>
+            <a:r>
+              <a:t>CÁC ĐIỂM NỔI BẬT</a:t>
             </a:r>
           </a:p>
           <a:p>
             <a:pPr>
               <a:spcAft>
-                <a:spcPts val="600"/>
+                <a:spcPts val="800"/>
               </a:spcAft>
               <a:defRPr sz="1050">
                 <a:solidFill>
@@ -4969,13 +5335,13 @@
               </a:defRPr>
             </a:pPr>
             <a:r>
-              <a:t>✔ Cửa hàng TMĐT: Duyệt 55 sản phẩm, giỏ hàng, đặt hàng COD, khóa chống trùng đơn.</a:t>
+              <a:t>✔ Avatar 3D tự động co giãn theo số đo Chiều cao &amp; Cân nặng người dùng.</a:t>
             </a:r>
           </a:p>
           <a:p>
             <a:pPr>
               <a:spcAft>
-                <a:spcPts val="600"/>
+                <a:spcPts val="800"/>
               </a:spcAft>
               <a:defRPr sz="1050">
                 <a:solidFill>
@@ -4984,13 +5350,13 @@
               </a:defRPr>
             </a:pPr>
             <a:r>
-              <a:t>✔ Trợ lý AI Stylist: Tư vấn vóc dáng, cá nhân hóa theo tìm kiếm &amp; đơn cũ.</a:t>
+              <a:t>✔ Chạy mượt mà trên nền tảng Three.js / WebGL, xoay 360 độ linh hoạt.</a:t>
             </a:r>
           </a:p>
           <a:p>
             <a:pPr>
               <a:spcAft>
-                <a:spcPts val="600"/>
+                <a:spcPts val="800"/>
               </a:spcAft>
               <a:defRPr sz="1050">
                 <a:solidFill>
@@ -4999,13 +5365,13 @@
               </a:defRPr>
             </a:pPr>
             <a:r>
-              <a:t>✔ Thẻ Combo Mua Sắm: Gợi ý 1 Áo + 1 Quần kèm nút Mua ngay 1-chạm.</a:t>
+              <a:t>✔ Thử các mẫu trang phục: Sơ mi Oxford, Áo thun Graphic, Quần tây đen, Váy.</a:t>
             </a:r>
           </a:p>
           <a:p>
             <a:pPr>
               <a:spcAft>
-                <a:spcPts val="600"/>
+                <a:spcPts val="800"/>
               </a:spcAft>
               <a:defRPr sz="1050">
                 <a:solidFill>
@@ -5014,62 +5380,72 @@
               </a:defRPr>
             </a:pPr>
             <a:r>
-              <a:t>✔ Phòng thử đồ 3D: Avatar co giãn theo số đo, xoay 360 độ, thẻ Fit Card.</a:t>
-            </a:r>
-          </a:p>
-          <a:p>
-            <a:pPr>
-              <a:spcAft>
-                <a:spcPts val="600"/>
-              </a:spcAft>
-              <a:defRPr sz="1050">
-                <a:solidFill>
-                  <a:srgbClr val="1E293B"/>
-                </a:solidFill>
-              </a:defRPr>
-            </a:pPr>
-            <a:r>
-              <a:t>✔ Quản trị Admin &amp; GHN: Tạo mã vận đơn bưu điện thật, in phiếu giao hàng A4/A5.</a:t>
-            </a:r>
-          </a:p>
-          <a:p>
-            <a:pPr>
-              <a:spcAft>
-                <a:spcPts val="600"/>
-              </a:spcAft>
-              <a:defRPr sz="1050">
-                <a:solidFill>
-                  <a:srgbClr val="1E293B"/>
-                </a:solidFill>
-              </a:defRPr>
-            </a:pPr>
-            <a:r>
-              <a:t>✔ Bộ kiểm thử tự động: 78 pytest, 60 node test, 70 vitest pass 100%.</a:t>
-            </a:r>
-          </a:p>
-        </p:txBody>
-      </p:sp>
-      <p:sp>
-        <p:nvSpPr>
-          <p:cNvPr id="8" name="Rounded Rectangle 7"/>
+              <a:t>✔ Đổi màu sắc trang phục linh hoạt theo các phiên bản màu sẵn có trong kho.</a:t>
+            </a:r>
+          </a:p>
+        </p:txBody>
+      </p:sp>
+      <p:pic>
+        <p:nvPicPr>
+          <p:cNvPr id="8" name="Picture 7" descr="shot_04_tryon.png"/>
+          <p:cNvPicPr>
+            <a:picLocks noChangeAspect="1"/>
+          </p:cNvPicPr>
+          <p:nvPr/>
+        </p:nvPicPr>
+        <p:blipFill>
+          <a:blip r:embed="rId2"/>
+          <a:stretch>
+            <a:fillRect/>
+          </a:stretch>
+        </p:blipFill>
+        <p:spPr>
+          <a:xfrm>
+            <a:off x="5029200" y="1554480"/>
+            <a:ext cx="6400800" cy="4846320"/>
+          </a:xfrm>
+          <a:prstGeom prst="rect">
+            <a:avLst/>
+          </a:prstGeom>
+        </p:spPr>
+      </p:pic>
+    </p:spTree>
+  </p:cSld>
+  <p:clrMapOvr>
+    <a:masterClrMapping/>
+  </p:clrMapOvr>
+</p:sld>
+</file>
+
+<file path=ppt/slides/slide7.xml><?xml version="1.0" encoding="utf-8"?>
+<p:sld xmlns:a="http://schemas.openxmlformats.org/drawingml/2006/main" xmlns:p="http://schemas.openxmlformats.org/presentationml/2006/main" xmlns:r="http://schemas.openxmlformats.org/officeDocument/2006/relationships">
+  <p:cSld>
+    <p:spTree>
+      <p:nvGrpSpPr>
+        <p:cNvPr id="1" name=""/>
+        <p:cNvGrpSpPr/>
+        <p:nvPr/>
+      </p:nvGrpSpPr>
+      <p:grpSpPr/>
+      <p:sp>
+        <p:nvSpPr>
+          <p:cNvPr id="2" name="Rectangle 1"/>
           <p:cNvSpPr/>
           <p:nvPr/>
         </p:nvSpPr>
         <p:spPr>
           <a:xfrm>
-            <a:off x="6126480" y="1645920"/>
-            <a:ext cx="5303520" cy="4754880"/>
-          </a:xfrm>
-          <a:prstGeom prst="roundRect">
+            <a:off x="0" y="0"/>
+            <a:ext cx="12188952" cy="6858000"/>
+          </a:xfrm>
+          <a:prstGeom prst="rect">
             <a:avLst/>
           </a:prstGeom>
           <a:solidFill>
-            <a:srgbClr val="FFFFFF"/>
+            <a:srgbClr val="F8FAFC"/>
           </a:solidFill>
           <a:ln>
-            <a:solidFill>
-              <a:srgbClr val="E2E8F0"/>
-            </a:solidFill>
+            <a:noFill/>
           </a:ln>
         </p:spPr>
         <p:style>
@@ -5096,14 +5472,14 @@
       </p:sp>
       <p:sp>
         <p:nvSpPr>
-          <p:cNvPr id="9" name="TextBox 8"/>
+          <p:cNvPr id="3" name="TextBox 2"/>
           <p:cNvSpPr txBox="1"/>
           <p:nvPr/>
         </p:nvSpPr>
         <p:spPr>
           <a:xfrm>
-            <a:off x="6309360" y="1828800"/>
-            <a:ext cx="4937760" cy="4389120"/>
+            <a:off x="731520" y="320040"/>
+            <a:ext cx="7315200" cy="320040"/>
           </a:xfrm>
           <a:prstGeom prst="rect">
             <a:avLst/>
@@ -5117,66 +5493,921 @@
           <a:lstStyle/>
           <a:p>
             <a:pPr>
+              <a:defRPr sz="1100" b="1">
+                <a:solidFill>
+                  <a:srgbClr val="2563EB"/>
+                </a:solidFill>
+              </a:defRPr>
+            </a:pPr>
+            <a:r>
+              <a:t>MÀN HÌNH 06</a:t>
+            </a:r>
+          </a:p>
+        </p:txBody>
+      </p:sp>
+      <p:sp>
+        <p:nvSpPr>
+          <p:cNvPr id="4" name="TextBox 3"/>
+          <p:cNvSpPr txBox="1"/>
+          <p:nvPr/>
+        </p:nvSpPr>
+        <p:spPr>
+          <a:xfrm>
+            <a:off x="731520" y="594360"/>
+            <a:ext cx="10515600" cy="502920"/>
+          </a:xfrm>
+          <a:prstGeom prst="rect">
+            <a:avLst/>
+          </a:prstGeom>
+          <a:noFill/>
+        </p:spPr>
+        <p:txBody>
+          <a:bodyPr wrap="square">
+            <a:spAutoFit/>
+          </a:bodyPr>
+          <a:lstStyle/>
+          <a:p>
+            <a:pPr>
+              <a:defRPr sz="2000" b="1">
+                <a:solidFill>
+                  <a:srgbClr val="0F172A"/>
+                </a:solidFill>
+              </a:defRPr>
+            </a:pPr>
+            <a:r>
+              <a:t>Dashboard Quản Trị Đơn Hàng Admin</a:t>
+            </a:r>
+          </a:p>
+        </p:txBody>
+      </p:sp>
+      <p:sp>
+        <p:nvSpPr>
+          <p:cNvPr id="5" name="TextBox 4"/>
+          <p:cNvSpPr txBox="1"/>
+          <p:nvPr/>
+        </p:nvSpPr>
+        <p:spPr>
+          <a:xfrm>
+            <a:off x="731520" y="1097280"/>
+            <a:ext cx="10515600" cy="320040"/>
+          </a:xfrm>
+          <a:prstGeom prst="rect">
+            <a:avLst/>
+          </a:prstGeom>
+          <a:noFill/>
+        </p:spPr>
+        <p:txBody>
+          <a:bodyPr wrap="square">
+            <a:spAutoFit/>
+          </a:bodyPr>
+          <a:lstStyle/>
+          <a:p>
+            <a:pPr>
+              <a:defRPr sz="1150">
+                <a:solidFill>
+                  <a:srgbClr val="64748B"/>
+                </a:solidFill>
+              </a:defRPr>
+            </a:pPr>
+            <a:r>
+              <a:t>Theo dõi tình trạng đơn hàng toàn hệ thống và điều phối giao vận</a:t>
+            </a:r>
+          </a:p>
+        </p:txBody>
+      </p:sp>
+      <p:sp>
+        <p:nvSpPr>
+          <p:cNvPr id="6" name="Rounded Rectangle 5"/>
+          <p:cNvSpPr/>
+          <p:nvPr/>
+        </p:nvSpPr>
+        <p:spPr>
+          <a:xfrm>
+            <a:off x="731520" y="1554480"/>
+            <a:ext cx="4114800" cy="4846320"/>
+          </a:xfrm>
+          <a:prstGeom prst="roundRect">
+            <a:avLst/>
+          </a:prstGeom>
+          <a:solidFill>
+            <a:srgbClr val="FFFFFF"/>
+          </a:solidFill>
+          <a:ln>
+            <a:solidFill>
+              <a:srgbClr val="E2E8F0"/>
+            </a:solidFill>
+          </a:ln>
+        </p:spPr>
+        <p:style>
+          <a:lnRef idx="1">
+            <a:schemeClr val="accent1"/>
+          </a:lnRef>
+          <a:fillRef idx="3">
+            <a:schemeClr val="accent1"/>
+          </a:fillRef>
+          <a:effectRef idx="2">
+            <a:schemeClr val="accent1"/>
+          </a:effectRef>
+          <a:fontRef idx="minor">
+            <a:schemeClr val="lt1"/>
+          </a:fontRef>
+        </p:style>
+        <p:txBody>
+          <a:bodyPr rtlCol="0" anchor="ctr"/>
+          <a:lstStyle/>
+          <a:p>
+            <a:pPr algn="ctr"/>
+          </a:p>
+        </p:txBody>
+      </p:sp>
+      <p:sp>
+        <p:nvSpPr>
+          <p:cNvPr id="7" name="TextBox 6"/>
+          <p:cNvSpPr txBox="1"/>
+          <p:nvPr/>
+        </p:nvSpPr>
+        <p:spPr>
+          <a:xfrm>
+            <a:off x="914400" y="1737360"/>
+            <a:ext cx="3749039" cy="4480560"/>
+          </a:xfrm>
+          <a:prstGeom prst="rect">
+            <a:avLst/>
+          </a:prstGeom>
+          <a:noFill/>
+        </p:spPr>
+        <p:txBody>
+          <a:bodyPr wrap="square">
+            <a:spAutoFit/>
+          </a:bodyPr>
+          <a:lstStyle/>
+          <a:p>
+            <a:pPr>
               <a:spcAft>
                 <a:spcPts val="1200"/>
               </a:spcAft>
-              <a:defRPr sz="1300" b="1">
-                <a:solidFill>
-                  <a:srgbClr val="D97706"/>
-                </a:solidFill>
-              </a:defRPr>
-            </a:pPr>
-            <a:r>
-              <a:t>TÍNH NĂNG CHƯA XONG / ĐANG LÀM</a:t>
+              <a:defRPr sz="1200" b="1">
+                <a:solidFill>
+                  <a:srgbClr val="2563EB"/>
+                </a:solidFill>
+              </a:defRPr>
+            </a:pPr>
+            <a:r>
+              <a:t>CÁC ĐIỂM NỔI BẬT</a:t>
             </a:r>
           </a:p>
           <a:p>
             <a:pPr>
               <a:spcAft>
-                <a:spcPts val="1000"/>
+                <a:spcPts val="800"/>
               </a:spcAft>
-              <a:defRPr sz="1100">
+              <a:defRPr sz="1050">
                 <a:solidFill>
                   <a:srgbClr val="1E293B"/>
                 </a:solidFill>
               </a:defRPr>
             </a:pPr>
             <a:r>
-              <a:t>⏳ Cổng thanh toán Chuyển khoản tự động: Hiện mới hỗ trợ thanh toán khi nhận hàng (COD), chưa tích hợp xong cổng đối soát tiền chuyển khoản qua ngân hàng.</a:t>
+              <a:t>✔ Dashboard Admin: Quản lý danh sách đơn hàng đã đặt của khách.</a:t>
             </a:r>
           </a:p>
           <a:p>
             <a:pPr>
               <a:spcAft>
-                <a:spcPts val="1000"/>
+                <a:spcPts val="800"/>
               </a:spcAft>
-              <a:defRPr sz="1100">
+              <a:defRPr sz="1050">
                 <a:solidFill>
                   <a:srgbClr val="1E293B"/>
                 </a:solidFill>
               </a:defRPr>
             </a:pPr>
             <a:r>
-              <a:t>⏳ Thử đồ thời gian thực qua Webcam: Tính năng ướm thử trang phục trực tiếp qua camera máy tính/điện thoại người dùng đang trong giai đoạn nghiên cứu.</a:t>
+              <a:t>✔ Xem chi tiết sản phẩm, số đo khách hàng, số điện thoại và địa chỉ giao hàng.</a:t>
             </a:r>
           </a:p>
           <a:p>
             <a:pPr>
               <a:spcAft>
-                <a:spcPts val="1000"/>
+                <a:spcPts val="800"/>
               </a:spcAft>
-              <a:defRPr sz="1100">
+              <a:defRPr sz="1050">
                 <a:solidFill>
                   <a:srgbClr val="1E293B"/>
                 </a:solidFill>
               </a:defRPr>
             </a:pPr>
             <a:r>
-              <a:t>⏳ Tinh chỉnh hiển thị phòng 3D: Cần hoàn thiện thêm độ khớp của phom đồ 3D và tối ưu hiệu năng hiển thị trên thiết bị di động (Mobile WebGL).</a:t>
-            </a:r>
-          </a:p>
-        </p:txBody>
-      </p:sp>
+              <a:t>✔ Nút duyệt đơn chuyển trạng thái sang Chuẩn bị đóng gói.</a:t>
+            </a:r>
+          </a:p>
+          <a:p>
+            <a:pPr>
+              <a:spcAft>
+                <a:spcPts val="800"/>
+              </a:spcAft>
+              <a:defRPr sz="1050">
+                <a:solidFill>
+                  <a:srgbClr val="1E293B"/>
+                </a:solidFill>
+              </a:defRPr>
+            </a:pPr>
+            <a:r>
+              <a:t>✔ Nút 'Tạo vận đơn GHN': Gọi API bưu điện Giao Hàng Nhanh sinh mã bưu cục thật.</a:t>
+            </a:r>
+          </a:p>
+        </p:txBody>
+      </p:sp>
+      <p:pic>
+        <p:nvPicPr>
+          <p:cNvPr id="8" name="Picture 7" descr="shot_06_admin.png"/>
+          <p:cNvPicPr>
+            <a:picLocks noChangeAspect="1"/>
+          </p:cNvPicPr>
+          <p:nvPr/>
+        </p:nvPicPr>
+        <p:blipFill>
+          <a:blip r:embed="rId2"/>
+          <a:stretch>
+            <a:fillRect/>
+          </a:stretch>
+        </p:blipFill>
+        <p:spPr>
+          <a:xfrm>
+            <a:off x="5029200" y="1554480"/>
+            <a:ext cx="6400800" cy="4846320"/>
+          </a:xfrm>
+          <a:prstGeom prst="rect">
+            <a:avLst/>
+          </a:prstGeom>
+        </p:spPr>
+      </p:pic>
+    </p:spTree>
+  </p:cSld>
+  <p:clrMapOvr>
+    <a:masterClrMapping/>
+  </p:clrMapOvr>
+</p:sld>
+</file>
+
+<file path=ppt/slides/slide8.xml><?xml version="1.0" encoding="utf-8"?>
+<p:sld xmlns:a="http://schemas.openxmlformats.org/drawingml/2006/main" xmlns:p="http://schemas.openxmlformats.org/presentationml/2006/main" xmlns:r="http://schemas.openxmlformats.org/officeDocument/2006/relationships">
+  <p:cSld>
+    <p:spTree>
+      <p:nvGrpSpPr>
+        <p:cNvPr id="1" name=""/>
+        <p:cNvGrpSpPr/>
+        <p:nvPr/>
+      </p:nvGrpSpPr>
+      <p:grpSpPr/>
+      <p:sp>
+        <p:nvSpPr>
+          <p:cNvPr id="2" name="Rectangle 1"/>
+          <p:cNvSpPr/>
+          <p:nvPr/>
+        </p:nvSpPr>
+        <p:spPr>
+          <a:xfrm>
+            <a:off x="0" y="0"/>
+            <a:ext cx="12188952" cy="6858000"/>
+          </a:xfrm>
+          <a:prstGeom prst="rect">
+            <a:avLst/>
+          </a:prstGeom>
+          <a:solidFill>
+            <a:srgbClr val="F8FAFC"/>
+          </a:solidFill>
+          <a:ln>
+            <a:noFill/>
+          </a:ln>
+        </p:spPr>
+        <p:style>
+          <a:lnRef idx="1">
+            <a:schemeClr val="accent1"/>
+          </a:lnRef>
+          <a:fillRef idx="3">
+            <a:schemeClr val="accent1"/>
+          </a:fillRef>
+          <a:effectRef idx="2">
+            <a:schemeClr val="accent1"/>
+          </a:effectRef>
+          <a:fontRef idx="minor">
+            <a:schemeClr val="lt1"/>
+          </a:fontRef>
+        </p:style>
+        <p:txBody>
+          <a:bodyPr rtlCol="0" anchor="ctr"/>
+          <a:lstStyle/>
+          <a:p>
+            <a:pPr algn="ctr"/>
+          </a:p>
+        </p:txBody>
+      </p:sp>
+      <p:sp>
+        <p:nvSpPr>
+          <p:cNvPr id="3" name="TextBox 2"/>
+          <p:cNvSpPr txBox="1"/>
+          <p:nvPr/>
+        </p:nvSpPr>
+        <p:spPr>
+          <a:xfrm>
+            <a:off x="731520" y="320040"/>
+            <a:ext cx="7315200" cy="320040"/>
+          </a:xfrm>
+          <a:prstGeom prst="rect">
+            <a:avLst/>
+          </a:prstGeom>
+          <a:noFill/>
+        </p:spPr>
+        <p:txBody>
+          <a:bodyPr wrap="square">
+            <a:spAutoFit/>
+          </a:bodyPr>
+          <a:lstStyle/>
+          <a:p>
+            <a:pPr>
+              <a:defRPr sz="1100" b="1">
+                <a:solidFill>
+                  <a:srgbClr val="2563EB"/>
+                </a:solidFill>
+              </a:defRPr>
+            </a:pPr>
+            <a:r>
+              <a:t>MÀN HÌNH 07</a:t>
+            </a:r>
+          </a:p>
+        </p:txBody>
+      </p:sp>
+      <p:sp>
+        <p:nvSpPr>
+          <p:cNvPr id="4" name="TextBox 3"/>
+          <p:cNvSpPr txBox="1"/>
+          <p:nvPr/>
+        </p:nvSpPr>
+        <p:spPr>
+          <a:xfrm>
+            <a:off x="731520" y="594360"/>
+            <a:ext cx="10515600" cy="502920"/>
+          </a:xfrm>
+          <a:prstGeom prst="rect">
+            <a:avLst/>
+          </a:prstGeom>
+          <a:noFill/>
+        </p:spPr>
+        <p:txBody>
+          <a:bodyPr wrap="square">
+            <a:spAutoFit/>
+          </a:bodyPr>
+          <a:lstStyle/>
+          <a:p>
+            <a:pPr>
+              <a:defRPr sz="2000" b="1">
+                <a:solidFill>
+                  <a:srgbClr val="0F172A"/>
+                </a:solidFill>
+              </a:defRPr>
+            </a:pPr>
+            <a:r>
+              <a:t>Bưu Cục Giao Hàng Nhanh Thật (5sao.ghn.dev)</a:t>
+            </a:r>
+          </a:p>
+        </p:txBody>
+      </p:sp>
+      <p:sp>
+        <p:nvSpPr>
+          <p:cNvPr id="5" name="TextBox 4"/>
+          <p:cNvSpPr txBox="1"/>
+          <p:nvPr/>
+        </p:nvSpPr>
+        <p:spPr>
+          <a:xfrm>
+            <a:off x="731520" y="1097280"/>
+            <a:ext cx="10515600" cy="320040"/>
+          </a:xfrm>
+          <a:prstGeom prst="rect">
+            <a:avLst/>
+          </a:prstGeom>
+          <a:noFill/>
+        </p:spPr>
+        <p:txBody>
+          <a:bodyPr wrap="square">
+            <a:spAutoFit/>
+          </a:bodyPr>
+          <a:lstStyle/>
+          <a:p>
+            <a:pPr>
+              <a:defRPr sz="1150">
+                <a:solidFill>
+                  <a:srgbClr val="64748B"/>
+                </a:solidFill>
+              </a:defRPr>
+            </a:pPr>
+            <a:r>
+              <a:t>Đơn hàng được đồng bộ tự động lên cổng bưu tá chính thức của GHN</a:t>
+            </a:r>
+          </a:p>
+        </p:txBody>
+      </p:sp>
+      <p:sp>
+        <p:nvSpPr>
+          <p:cNvPr id="6" name="Rounded Rectangle 5"/>
+          <p:cNvSpPr/>
+          <p:nvPr/>
+        </p:nvSpPr>
+        <p:spPr>
+          <a:xfrm>
+            <a:off x="731520" y="1554480"/>
+            <a:ext cx="4114800" cy="4846320"/>
+          </a:xfrm>
+          <a:prstGeom prst="roundRect">
+            <a:avLst/>
+          </a:prstGeom>
+          <a:solidFill>
+            <a:srgbClr val="FFFFFF"/>
+          </a:solidFill>
+          <a:ln>
+            <a:solidFill>
+              <a:srgbClr val="E2E8F0"/>
+            </a:solidFill>
+          </a:ln>
+        </p:spPr>
+        <p:style>
+          <a:lnRef idx="1">
+            <a:schemeClr val="accent1"/>
+          </a:lnRef>
+          <a:fillRef idx="3">
+            <a:schemeClr val="accent1"/>
+          </a:fillRef>
+          <a:effectRef idx="2">
+            <a:schemeClr val="accent1"/>
+          </a:effectRef>
+          <a:fontRef idx="minor">
+            <a:schemeClr val="lt1"/>
+          </a:fontRef>
+        </p:style>
+        <p:txBody>
+          <a:bodyPr rtlCol="0" anchor="ctr"/>
+          <a:lstStyle/>
+          <a:p>
+            <a:pPr algn="ctr"/>
+          </a:p>
+        </p:txBody>
+      </p:sp>
+      <p:sp>
+        <p:nvSpPr>
+          <p:cNvPr id="7" name="TextBox 6"/>
+          <p:cNvSpPr txBox="1"/>
+          <p:nvPr/>
+        </p:nvSpPr>
+        <p:spPr>
+          <a:xfrm>
+            <a:off x="914400" y="1737360"/>
+            <a:ext cx="3749039" cy="4480560"/>
+          </a:xfrm>
+          <a:prstGeom prst="rect">
+            <a:avLst/>
+          </a:prstGeom>
+          <a:noFill/>
+        </p:spPr>
+        <p:txBody>
+          <a:bodyPr wrap="square">
+            <a:spAutoFit/>
+          </a:bodyPr>
+          <a:lstStyle/>
+          <a:p>
+            <a:pPr>
+              <a:spcAft>
+                <a:spcPts val="1200"/>
+              </a:spcAft>
+              <a:defRPr sz="1200" b="1">
+                <a:solidFill>
+                  <a:srgbClr val="2563EB"/>
+                </a:solidFill>
+              </a:defRPr>
+            </a:pPr>
+            <a:r>
+              <a:t>CÁC ĐIỂM NỔI BẬT</a:t>
+            </a:r>
+          </a:p>
+          <a:p>
+            <a:pPr>
+              <a:spcAft>
+                <a:spcPts val="800"/>
+              </a:spcAft>
+              <a:defRPr sz="1050">
+                <a:solidFill>
+                  <a:srgbClr val="1E293B"/>
+                </a:solidFill>
+              </a:defRPr>
+            </a:pPr>
+            <a:r>
+              <a:t>✔ Kết nối API GHN Sandbox thực tế với Shop ID chính thức: 233442.</a:t>
+            </a:r>
+          </a:p>
+          <a:p>
+            <a:pPr>
+              <a:spcAft>
+                <a:spcPts val="800"/>
+              </a:spcAft>
+              <a:defRPr sz="1050">
+                <a:solidFill>
+                  <a:srgbClr val="1E293B"/>
+                </a:solidFill>
+              </a:defRPr>
+            </a:pPr>
+            <a:r>
+              <a:t>✔ Tự động tính cước vận chuyển chuẩn bưu điện và khớp tiền thu hộ COD.</a:t>
+            </a:r>
+          </a:p>
+          <a:p>
+            <a:pPr>
+              <a:spcAft>
+                <a:spcPts val="800"/>
+              </a:spcAft>
+              <a:defRPr sz="1050">
+                <a:solidFill>
+                  <a:srgbClr val="1E293B"/>
+                </a:solidFill>
+              </a:defRPr>
+            </a:pPr>
+            <a:r>
+              <a:t>✔ Đơn hàng hiển thị ngay lập tức trên hệ thống điều phối bưu tá GHN.</a:t>
+            </a:r>
+          </a:p>
+          <a:p>
+            <a:pPr>
+              <a:spcAft>
+                <a:spcPts val="800"/>
+              </a:spcAft>
+              <a:defRPr sz="1050">
+                <a:solidFill>
+                  <a:srgbClr val="1E293B"/>
+                </a:solidFill>
+              </a:defRPr>
+            </a:pPr>
+            <a:r>
+              <a:t>✔ Mã vận đơn chính thức (VD: LYQGW4) cập nhật xuyên suốt cho khách tra cứu.</a:t>
+            </a:r>
+          </a:p>
+        </p:txBody>
+      </p:sp>
+      <p:pic>
+        <p:nvPicPr>
+          <p:cNvPr id="8" name="Picture 7" descr="shot_07_ghn_dashboard.png"/>
+          <p:cNvPicPr>
+            <a:picLocks noChangeAspect="1"/>
+          </p:cNvPicPr>
+          <p:nvPr/>
+        </p:nvPicPr>
+        <p:blipFill>
+          <a:blip r:embed="rId2"/>
+          <a:stretch>
+            <a:fillRect/>
+          </a:stretch>
+        </p:blipFill>
+        <p:spPr>
+          <a:xfrm>
+            <a:off x="5029200" y="1554480"/>
+            <a:ext cx="6400800" cy="4846320"/>
+          </a:xfrm>
+          <a:prstGeom prst="rect">
+            <a:avLst/>
+          </a:prstGeom>
+        </p:spPr>
+      </p:pic>
+    </p:spTree>
+  </p:cSld>
+  <p:clrMapOvr>
+    <a:masterClrMapping/>
+  </p:clrMapOvr>
+</p:sld>
+</file>
+
+<file path=ppt/slides/slide9.xml><?xml version="1.0" encoding="utf-8"?>
+<p:sld xmlns:a="http://schemas.openxmlformats.org/drawingml/2006/main" xmlns:p="http://schemas.openxmlformats.org/presentationml/2006/main" xmlns:r="http://schemas.openxmlformats.org/officeDocument/2006/relationships">
+  <p:cSld>
+    <p:spTree>
+      <p:nvGrpSpPr>
+        <p:cNvPr id="1" name=""/>
+        <p:cNvGrpSpPr/>
+        <p:nvPr/>
+      </p:nvGrpSpPr>
+      <p:grpSpPr/>
+      <p:sp>
+        <p:nvSpPr>
+          <p:cNvPr id="2" name="Rectangle 1"/>
+          <p:cNvSpPr/>
+          <p:nvPr/>
+        </p:nvSpPr>
+        <p:spPr>
+          <a:xfrm>
+            <a:off x="0" y="0"/>
+            <a:ext cx="12188952" cy="6858000"/>
+          </a:xfrm>
+          <a:prstGeom prst="rect">
+            <a:avLst/>
+          </a:prstGeom>
+          <a:solidFill>
+            <a:srgbClr val="F8FAFC"/>
+          </a:solidFill>
+          <a:ln>
+            <a:noFill/>
+          </a:ln>
+        </p:spPr>
+        <p:style>
+          <a:lnRef idx="1">
+            <a:schemeClr val="accent1"/>
+          </a:lnRef>
+          <a:fillRef idx="3">
+            <a:schemeClr val="accent1"/>
+          </a:fillRef>
+          <a:effectRef idx="2">
+            <a:schemeClr val="accent1"/>
+          </a:effectRef>
+          <a:fontRef idx="minor">
+            <a:schemeClr val="lt1"/>
+          </a:fontRef>
+        </p:style>
+        <p:txBody>
+          <a:bodyPr rtlCol="0" anchor="ctr"/>
+          <a:lstStyle/>
+          <a:p>
+            <a:pPr algn="ctr"/>
+          </a:p>
+        </p:txBody>
+      </p:sp>
+      <p:sp>
+        <p:nvSpPr>
+          <p:cNvPr id="3" name="TextBox 2"/>
+          <p:cNvSpPr txBox="1"/>
+          <p:nvPr/>
+        </p:nvSpPr>
+        <p:spPr>
+          <a:xfrm>
+            <a:off x="731520" y="320040"/>
+            <a:ext cx="7315200" cy="320040"/>
+          </a:xfrm>
+          <a:prstGeom prst="rect">
+            <a:avLst/>
+          </a:prstGeom>
+          <a:noFill/>
+        </p:spPr>
+        <p:txBody>
+          <a:bodyPr wrap="square">
+            <a:spAutoFit/>
+          </a:bodyPr>
+          <a:lstStyle/>
+          <a:p>
+            <a:pPr>
+              <a:defRPr sz="1100" b="1">
+                <a:solidFill>
+                  <a:srgbClr val="2563EB"/>
+                </a:solidFill>
+              </a:defRPr>
+            </a:pPr>
+            <a:r>
+              <a:t>MÀN HÌNH 08</a:t>
+            </a:r>
+          </a:p>
+        </p:txBody>
+      </p:sp>
+      <p:sp>
+        <p:nvSpPr>
+          <p:cNvPr id="4" name="TextBox 3"/>
+          <p:cNvSpPr txBox="1"/>
+          <p:nvPr/>
+        </p:nvSpPr>
+        <p:spPr>
+          <a:xfrm>
+            <a:off x="731520" y="594360"/>
+            <a:ext cx="10515600" cy="502920"/>
+          </a:xfrm>
+          <a:prstGeom prst="rect">
+            <a:avLst/>
+          </a:prstGeom>
+          <a:noFill/>
+        </p:spPr>
+        <p:txBody>
+          <a:bodyPr wrap="square">
+            <a:spAutoFit/>
+          </a:bodyPr>
+          <a:lstStyle/>
+          <a:p>
+            <a:pPr>
+              <a:defRPr sz="2000" b="1">
+                <a:solidFill>
+                  <a:srgbClr val="0F172A"/>
+                </a:solidFill>
+              </a:defRPr>
+            </a:pPr>
+            <a:r>
+              <a:t>Phiếu In Giao Hàng Bưu Điện Khổ A4/A5</a:t>
+            </a:r>
+          </a:p>
+        </p:txBody>
+      </p:sp>
+      <p:sp>
+        <p:nvSpPr>
+          <p:cNvPr id="5" name="TextBox 4"/>
+          <p:cNvSpPr txBox="1"/>
+          <p:nvPr/>
+        </p:nvSpPr>
+        <p:spPr>
+          <a:xfrm>
+            <a:off x="731520" y="1097280"/>
+            <a:ext cx="10515600" cy="320040"/>
+          </a:xfrm>
+          <a:prstGeom prst="rect">
+            <a:avLst/>
+          </a:prstGeom>
+          <a:noFill/>
+        </p:spPr>
+        <p:txBody>
+          <a:bodyPr wrap="square">
+            <a:spAutoFit/>
+          </a:bodyPr>
+          <a:lstStyle/>
+          <a:p>
+            <a:pPr>
+              <a:defRPr sz="1150">
+                <a:solidFill>
+                  <a:srgbClr val="64748B"/>
+                </a:solidFill>
+              </a:defRPr>
+            </a:pPr>
+            <a:r>
+              <a:t>Tự động sinh mã vạch Barcode SVG, ô tiền COD nổi bật để dán thùng hàng</a:t>
+            </a:r>
+          </a:p>
+        </p:txBody>
+      </p:sp>
+      <p:sp>
+        <p:nvSpPr>
+          <p:cNvPr id="6" name="Rounded Rectangle 5"/>
+          <p:cNvSpPr/>
+          <p:nvPr/>
+        </p:nvSpPr>
+        <p:spPr>
+          <a:xfrm>
+            <a:off x="731520" y="1554480"/>
+            <a:ext cx="4114800" cy="4846320"/>
+          </a:xfrm>
+          <a:prstGeom prst="roundRect">
+            <a:avLst/>
+          </a:prstGeom>
+          <a:solidFill>
+            <a:srgbClr val="FFFFFF"/>
+          </a:solidFill>
+          <a:ln>
+            <a:solidFill>
+              <a:srgbClr val="E2E8F0"/>
+            </a:solidFill>
+          </a:ln>
+        </p:spPr>
+        <p:style>
+          <a:lnRef idx="1">
+            <a:schemeClr val="accent1"/>
+          </a:lnRef>
+          <a:fillRef idx="3">
+            <a:schemeClr val="accent1"/>
+          </a:fillRef>
+          <a:effectRef idx="2">
+            <a:schemeClr val="accent1"/>
+          </a:effectRef>
+          <a:fontRef idx="minor">
+            <a:schemeClr val="lt1"/>
+          </a:fontRef>
+        </p:style>
+        <p:txBody>
+          <a:bodyPr rtlCol="0" anchor="ctr"/>
+          <a:lstStyle/>
+          <a:p>
+            <a:pPr algn="ctr"/>
+          </a:p>
+        </p:txBody>
+      </p:sp>
+      <p:sp>
+        <p:nvSpPr>
+          <p:cNvPr id="7" name="TextBox 6"/>
+          <p:cNvSpPr txBox="1"/>
+          <p:nvPr/>
+        </p:nvSpPr>
+        <p:spPr>
+          <a:xfrm>
+            <a:off x="914400" y="1737360"/>
+            <a:ext cx="3749039" cy="4480560"/>
+          </a:xfrm>
+          <a:prstGeom prst="rect">
+            <a:avLst/>
+          </a:prstGeom>
+          <a:noFill/>
+        </p:spPr>
+        <p:txBody>
+          <a:bodyPr wrap="square">
+            <a:spAutoFit/>
+          </a:bodyPr>
+          <a:lstStyle/>
+          <a:p>
+            <a:pPr>
+              <a:spcAft>
+                <a:spcPts val="1200"/>
+              </a:spcAft>
+              <a:defRPr sz="1200" b="1">
+                <a:solidFill>
+                  <a:srgbClr val="2563EB"/>
+                </a:solidFill>
+              </a:defRPr>
+            </a:pPr>
+            <a:r>
+              <a:t>CÁC ĐIỂM NỔI BẬT</a:t>
+            </a:r>
+          </a:p>
+          <a:p>
+            <a:pPr>
+              <a:spcAft>
+                <a:spcPts val="800"/>
+              </a:spcAft>
+              <a:defRPr sz="1050">
+                <a:solidFill>
+                  <a:srgbClr val="1E293B"/>
+                </a:solidFill>
+              </a:defRPr>
+            </a:pPr>
+            <a:r>
+              <a:t>✔ 1-Click bấm 'In phiếu giao hàng / Xuất PDF' ngay trên giao diện đơn hàng.</a:t>
+            </a:r>
+          </a:p>
+          <a:p>
+            <a:pPr>
+              <a:spcAft>
+                <a:spcPts val="800"/>
+              </a:spcAft>
+              <a:defRPr sz="1050">
+                <a:solidFill>
+                  <a:srgbClr val="1E293B"/>
+                </a:solidFill>
+              </a:defRPr>
+            </a:pPr>
+            <a:r>
+              <a:t>✔ Mẫu in chuẩn bưu điện: Thông tin shop gửi, thông tin người nhận rõ ràng.</a:t>
+            </a:r>
+          </a:p>
+          <a:p>
+            <a:pPr>
+              <a:spcAft>
+                <a:spcPts val="800"/>
+              </a:spcAft>
+              <a:defRPr sz="1050">
+                <a:solidFill>
+                  <a:srgbClr val="1E293B"/>
+                </a:solidFill>
+              </a:defRPr>
+            </a:pPr>
+            <a:r>
+              <a:t>✔ Mã vạch Barcode SVG sắc nét phục vụ máy quét bưu cục khi lấy hàng.</a:t>
+            </a:r>
+          </a:p>
+          <a:p>
+            <a:pPr>
+              <a:spcAft>
+                <a:spcPts val="800"/>
+              </a:spcAft>
+              <a:defRPr sz="1050">
+                <a:solidFill>
+                  <a:srgbClr val="1E293B"/>
+                </a:solidFill>
+              </a:defRPr>
+            </a:pPr>
+            <a:r>
+              <a:t>✔ Khung tiền thu hộ COD nổi bật và chữ ký bàn giao chuẩn quy cách.</a:t>
+            </a:r>
+          </a:p>
+        </p:txBody>
+      </p:sp>
+      <p:pic>
+        <p:nvPicPr>
+          <p:cNvPr id="8" name="Picture 7" descr="shot_08_ghn_print_slip.png"/>
+          <p:cNvPicPr>
+            <a:picLocks noChangeAspect="1"/>
+          </p:cNvPicPr>
+          <p:nvPr/>
+        </p:nvPicPr>
+        <p:blipFill>
+          <a:blip r:embed="rId2"/>
+          <a:stretch>
+            <a:fillRect/>
+          </a:stretch>
+        </p:blipFill>
+        <p:spPr>
+          <a:xfrm>
+            <a:off x="5029200" y="1554480"/>
+            <a:ext cx="6400800" cy="4846320"/>
+          </a:xfrm>
+          <a:prstGeom prst="rect">
+            <a:avLst/>
+          </a:prstGeom>
+        </p:spPr>
+      </p:pic>
     </p:spTree>
   </p:cSld>
   <p:clrMapOvr>

</xml_diff>